<commit_message>
docs: sync report with real Optuna tuning
</commit_message>
<xml_diff>
--- a/docs/Slide_Thuyet_Trinh_MLOps_Customer_Churn.pptx
+++ b/docs/Slide_Thuyet_Trinh_MLOps_Customer_Churn.pptx
@@ -20,6 +20,7 @@
     <p:sldId id="268" r:id="rId20"/>
     <p:sldId id="269" r:id="rId21"/>
     <p:sldId id="270" r:id="rId22"/>
+    <p:sldId id="271" r:id="rId23"/>
   </p:sldIdLst>
   <p:sldSz cx="12191695" cy="6858000" type="screen4x3"/>
   <p:notesSz cx="6858000" cy="9144000"/>
@@ -586,7 +587,7 @@
           <a:lstStyle/>
           <a:p>
             <a:r>
-              <a:t>Nhóm tích hợp SHAP TreeExplainer thực tế để bóc tách nguyên nhân rời bỏ cho từng khách hàng, phục vụ quyết định kinh doanh cá nhân hóa.</a:t>
+              <a:t>Đây là đóng góp trung thực mang tính học thuật cao của nhóm: phát hiện tập dữ liệu có quy luật gần như định thức ở thuộc tính Contract Length, giải thích rõ nguyên nhân ROC-AUC cao.</a:t>
             </a:r>
           </a:p>
         </p:txBody>
@@ -656,7 +657,7 @@
           <a:lstStyle/>
           <a:p>
             <a:r>
-              <a:t>API hỗ trợ cả hai phương thức: gửi JSON trực tiếp hoặc truy xuất tự động từ Feast Online Store theo Customer ID.</a:t>
+              <a:t>Nhóm tích hợp SHAP TreeExplainer thực tế để bóc tách nguyên nhân rời bỏ cho từng khách hàng, phục vụ quyết định kinh doanh cá nhân hóa.</a:t>
             </a:r>
           </a:p>
         </p:txBody>
@@ -726,7 +727,7 @@
           <a:lstStyle/>
           <a:p>
             <a:r>
-              <a:t>Module giám sát trôi dạt dữ liệu kết hợp kiểm định KS-test và PSI, có sẵn webhook để kích hoạt Continuous Training tự động.</a:t>
+              <a:t>API hỗ trợ cả hai phương thức: gửi JSON trực tiếp hoặc truy xuất tự động từ Feast Online Store theo Customer ID.</a:t>
             </a:r>
           </a:p>
         </p:txBody>
@@ -796,7 +797,7 @@
           <a:lstStyle/>
           <a:p>
             <a:r>
-              <a:t>Pipeline CI/CD hoàn chỉnh kiểm tra toàn bộ chất lượng code, tính toàn vẹn DVC, unit tests và kiểm thử docker build.</a:t>
+              <a:t>Module giám sát trôi dạt dữ liệu kết hợp kiểm định KS-test và PSI, có sẵn webhook để kích hoạt Continuous Training tự động.</a:t>
             </a:r>
           </a:p>
         </p:txBody>
@@ -866,6 +867,76 @@
           <a:lstStyle/>
           <a:p>
             <a:r>
+              <a:t>Pipeline CI/CD hoàn chỉnh kiểm tra toàn bộ chất lượng code, tính toàn vẹn DVC, unit tests và kiểm thử docker build.</a:t>
+            </a:r>
+          </a:p>
+        </p:txBody>
+      </p:sp>
+      <p:sp>
+        <p:nvSpPr>
+          <p:cNvPr id="4" name="Slide Number Placeholder 3"/>
+          <p:cNvSpPr>
+            <a:spLocks noGrp="1"/>
+          </p:cNvSpPr>
+          <p:nvPr>
+            <p:ph type="sldNum" idx="5" sz="quarter"/>
+          </p:nvPr>
+        </p:nvSpPr>
+        <p:spPr/>
+      </p:sp>
+    </p:spTree>
+  </p:cSld>
+  <p:clrMapOvr>
+    <a:masterClrMapping/>
+  </p:clrMapOvr>
+</p:notes>
+</file>
+
+<file path=ppt/notesSlides/notesSlide15.xml><?xml version="1.0" encoding="utf-8"?>
+<p:notes xmlns:a="http://schemas.openxmlformats.org/drawingml/2006/main" xmlns:p="http://schemas.openxmlformats.org/presentationml/2006/main" xmlns:r="http://schemas.openxmlformats.org/officeDocument/2006/relationships">
+  <p:cSld>
+    <p:spTree>
+      <p:nvGrpSpPr>
+        <p:cNvPr id="1" name=""/>
+        <p:cNvGrpSpPr/>
+        <p:nvPr/>
+      </p:nvGrpSpPr>
+      <p:grpSpPr>
+        <a:xfrm>
+          <a:off x="0" y="0"/>
+          <a:ext cx="0" cy="0"/>
+          <a:chOff x="0" y="0"/>
+          <a:chExt cx="0" cy="0"/>
+        </a:xfrm>
+      </p:grpSpPr>
+      <p:sp>
+        <p:nvSpPr>
+          <p:cNvPr id="2" name="Slide Image Placeholder 1"/>
+          <p:cNvSpPr>
+            <a:spLocks noGrp="1"/>
+          </p:cNvSpPr>
+          <p:nvPr>
+            <p:ph type="sldImg" idx="2"/>
+          </p:nvPr>
+        </p:nvSpPr>
+        <p:spPr/>
+      </p:sp>
+      <p:sp>
+        <p:nvSpPr>
+          <p:cNvPr id="3" name="Notes Placeholder 2"/>
+          <p:cNvSpPr>
+            <a:spLocks noGrp="1"/>
+          </p:cNvSpPr>
+          <p:nvPr>
+            <p:ph type="body" idx="3" sz="quarter"/>
+          </p:nvPr>
+        </p:nvSpPr>
+        <p:spPr/>
+        <p:txBody>
+          <a:bodyPr/>
+          <a:lstStyle/>
+          <a:p>
+            <a:r>
               <a:t>Đồ án đã sẵn sàng cho buổi bảo vệ với kịch bản demo thực tế trên hệ thống đang chạy.</a:t>
             </a:r>
           </a:p>
@@ -1356,7 +1427,7 @@
           <a:lstStyle/>
           <a:p>
             <a:r>
-              <a:t>Đồ thị ROC curves minh chứng khả năng phân loại vượt trội của các mô hình Gradient Boosting và Random Forest so với Logistic Regression.</a:t>
+              <a:t>Nhóm ứng dụng Optuna Bayesian Optimization với 12 trials, tự động tối ưu hóa siêu tham số cho cả Champion và Challenger.</a:t>
             </a:r>
           </a:p>
         </p:txBody>
@@ -1426,7 +1497,7 @@
           <a:lstStyle/>
           <a:p>
             <a:r>
-              <a:t>Đây là đóng góp trung thực mang tính học thuật cao của nhóm: phát hiện tập dữ liệu có quy luật gần như định thức ở thuộc tính Contract Length, giải thích rõ nguyên nhân ROC-AUC cao.</a:t>
+              <a:t>Đồ thị ROC curves minh chứng khả năng phân loại vượt trội của các mô hình Gradient Boosting và Random Forest so với Logistic Regression.</a:t>
             </a:r>
           </a:p>
         </p:txBody>
@@ -4604,6 +4675,221 @@
               </a:defRPr>
             </a:pPr>
             <a:r>
+              <a:t>4.0 ĐÁNH GIÁ ĐƯỜNG CONG ROC &amp; AUC</a:t>
+            </a:r>
+          </a:p>
+          <a:p>
+            <a:pPr>
+              <a:defRPr sz="2100" b="1">
+                <a:solidFill>
+                  <a:srgbClr val="F8FAFC"/>
+                </a:solidFill>
+                <a:latin typeface="Arial"/>
+              </a:defRPr>
+            </a:pPr>
+            <a:r>
+              <a:t>Khả Năng Phân Tách Nhị Phân &amp; Ma Trận Nhầm Lẫn</a:t>
+            </a:r>
+          </a:p>
+        </p:txBody>
+      </p:sp>
+      <p:sp>
+        <p:nvSpPr>
+          <p:cNvPr id="3" name="Rounded Rectangle 2"/>
+          <p:cNvSpPr/>
+          <p:nvPr/>
+        </p:nvSpPr>
+        <p:spPr>
+          <a:xfrm>
+            <a:off x="731520" y="1554480"/>
+            <a:ext cx="5486400" cy="4754880"/>
+          </a:xfrm>
+          <a:prstGeom prst="roundRect">
+            <a:avLst/>
+          </a:prstGeom>
+          <a:solidFill>
+            <a:srgbClr val="112240"/>
+          </a:solidFill>
+          <a:ln>
+            <a:solidFill>
+              <a:srgbClr val="233554"/>
+            </a:solidFill>
+          </a:ln>
+        </p:spPr>
+        <p:style>
+          <a:lnRef idx="1">
+            <a:schemeClr val="accent1"/>
+          </a:lnRef>
+          <a:fillRef idx="3">
+            <a:schemeClr val="accent1"/>
+          </a:fillRef>
+          <a:effectRef idx="2">
+            <a:schemeClr val="accent1"/>
+          </a:effectRef>
+          <a:fontRef idx="minor">
+            <a:schemeClr val="lt1"/>
+          </a:fontRef>
+        </p:style>
+        <p:txBody>
+          <a:bodyPr rtlCol="0" anchor="ctr"/>
+          <a:lstStyle/>
+          <a:p>
+            <a:pPr algn="ctr"/>
+          </a:p>
+        </p:txBody>
+      </p:sp>
+      <p:sp>
+        <p:nvSpPr>
+          <p:cNvPr id="4" name="TextBox 3"/>
+          <p:cNvSpPr txBox="1"/>
+          <p:nvPr/>
+        </p:nvSpPr>
+        <p:spPr>
+          <a:xfrm>
+            <a:off x="1005840" y="1737360"/>
+            <a:ext cx="4937760" cy="4297680"/>
+          </a:xfrm>
+          <a:prstGeom prst="rect">
+            <a:avLst/>
+          </a:prstGeom>
+          <a:noFill/>
+        </p:spPr>
+        <p:txBody>
+          <a:bodyPr wrap="square">
+            <a:spAutoFit/>
+          </a:bodyPr>
+          <a:lstStyle/>
+          <a:p>
+            <a:pPr>
+              <a:spcAft>
+                <a:spcPts val="1000"/>
+              </a:spcAft>
+              <a:defRPr sz="1400">
+                <a:solidFill>
+                  <a:srgbClr val="F8FAFC"/>
+                </a:solidFill>
+                <a:latin typeface="Arial"/>
+              </a:defRPr>
+            </a:pPr>
+            <a:r>
+              <a:t>•  Đường cong ROC tiến sát góc trên bên trái, chứng minh độ nhạy cực cao.</a:t>
+            </a:r>
+          </a:p>
+          <a:p>
+            <a:pPr>
+              <a:spcAft>
+                <a:spcPts val="1000"/>
+              </a:spcAft>
+              <a:defRPr sz="1400">
+                <a:solidFill>
+                  <a:srgbClr val="F8FAFC"/>
+                </a:solidFill>
+                <a:latin typeface="Arial"/>
+              </a:defRPr>
+            </a:pPr>
+            <a:r>
+              <a:t>•  Test Accuracy đạt trên 99.8% cho các mô hình dạng cây, vượt trội so với Baseline (87.27%).</a:t>
+            </a:r>
+          </a:p>
+          <a:p>
+            <a:pPr>
+              <a:spcAft>
+                <a:spcPts val="1000"/>
+              </a:spcAft>
+              <a:defRPr sz="1400">
+                <a:solidFill>
+                  <a:srgbClr val="F8FAFC"/>
+                </a:solidFill>
+                <a:latin typeface="Arial"/>
+              </a:defRPr>
+            </a:pPr>
+            <a:r>
+              <a:t>•  Tối thiểu hóa False Negatives (khách hàng rời bỏ nhưng đoán nhầm là ở lại), bảo toàn doanh thu doanh nghiệp.</a:t>
+            </a:r>
+          </a:p>
+        </p:txBody>
+      </p:sp>
+      <p:pic>
+        <p:nvPicPr>
+          <p:cNvPr id="5" name="Picture 4" descr="roc_curves.png"/>
+          <p:cNvPicPr>
+            <a:picLocks noChangeAspect="1"/>
+          </p:cNvPicPr>
+          <p:nvPr/>
+        </p:nvPicPr>
+        <p:blipFill>
+          <a:blip r:embed="rId2"/>
+          <a:stretch>
+            <a:fillRect/>
+          </a:stretch>
+        </p:blipFill>
+        <p:spPr>
+          <a:xfrm>
+            <a:off x="6492240" y="1554480"/>
+            <a:ext cx="4937760" cy="4232366"/>
+          </a:xfrm>
+          <a:prstGeom prst="rect">
+            <a:avLst/>
+          </a:prstGeom>
+        </p:spPr>
+      </p:pic>
+    </p:spTree>
+  </p:cSld>
+  <p:clrMapOvr>
+    <a:masterClrMapping/>
+  </p:clrMapOvr>
+</p:sld>
+</file>
+
+<file path=ppt/slides/slide11.xml><?xml version="1.0" encoding="utf-8"?>
+<p:sld xmlns:a="http://schemas.openxmlformats.org/drawingml/2006/main" xmlns:p="http://schemas.openxmlformats.org/presentationml/2006/main" xmlns:r="http://schemas.openxmlformats.org/officeDocument/2006/relationships">
+  <p:cSld>
+    <p:bg>
+      <p:bgPr>
+        <a:solidFill>
+          <a:srgbClr val="0A192F"/>
+        </a:solidFill>
+        <a:effectLst/>
+      </p:bgPr>
+    </p:bg>
+    <p:spTree>
+      <p:nvGrpSpPr>
+        <p:cNvPr id="1" name=""/>
+        <p:cNvGrpSpPr/>
+        <p:nvPr/>
+      </p:nvGrpSpPr>
+      <p:grpSpPr/>
+      <p:sp>
+        <p:nvSpPr>
+          <p:cNvPr id="2" name="TextBox 1"/>
+          <p:cNvSpPr txBox="1"/>
+          <p:nvPr/>
+        </p:nvSpPr>
+        <p:spPr>
+          <a:xfrm>
+            <a:off x="731520" y="320040"/>
+            <a:ext cx="10698480" cy="1005840"/>
+          </a:xfrm>
+          <a:prstGeom prst="rect">
+            <a:avLst/>
+          </a:prstGeom>
+          <a:noFill/>
+        </p:spPr>
+        <p:txBody>
+          <a:bodyPr wrap="square">
+            <a:spAutoFit/>
+          </a:bodyPr>
+          <a:lstStyle/>
+          <a:p>
+            <a:pPr>
+              <a:defRPr sz="1000" b="1">
+                <a:solidFill>
+                  <a:srgbClr val="F59E0B"/>
+                </a:solidFill>
+                <a:latin typeface="Arial"/>
+              </a:defRPr>
+            </a:pPr>
+            <a:r>
               <a:t>4.0 PHÂN TÍCH GIỚI HẠN DỮ LIỆU (DATA BIAS)</a:t>
             </a:r>
           </a:p>
@@ -4786,7 +5072,7 @@
 </p:sld>
 </file>
 
-<file path=ppt/slides/slide11.xml><?xml version="1.0" encoding="utf-8"?>
+<file path=ppt/slides/slide12.xml><?xml version="1.0" encoding="utf-8"?>
 <p:sld xmlns:a="http://schemas.openxmlformats.org/drawingml/2006/main" xmlns:p="http://schemas.openxmlformats.org/presentationml/2006/main" xmlns:r="http://schemas.openxmlformats.org/officeDocument/2006/relationships">
   <p:cSld>
     <p:bg>
@@ -5017,7 +5303,7 @@
 </p:sld>
 </file>
 
-<file path=ppt/slides/slide12.xml><?xml version="1.0" encoding="utf-8"?>
+<file path=ppt/slides/slide13.xml><?xml version="1.0" encoding="utf-8"?>
 <p:sld xmlns:a="http://schemas.openxmlformats.org/drawingml/2006/main" xmlns:p="http://schemas.openxmlformats.org/presentationml/2006/main" xmlns:r="http://schemas.openxmlformats.org/officeDocument/2006/relationships">
   <p:cSld>
     <p:bg>
@@ -5248,7 +5534,7 @@
 </p:sld>
 </file>
 
-<file path=ppt/slides/slide13.xml><?xml version="1.0" encoding="utf-8"?>
+<file path=ppt/slides/slide14.xml><?xml version="1.0" encoding="utf-8"?>
 <p:sld xmlns:a="http://schemas.openxmlformats.org/drawingml/2006/main" xmlns:p="http://schemas.openxmlformats.org/presentationml/2006/main" xmlns:r="http://schemas.openxmlformats.org/officeDocument/2006/relationships">
   <p:cSld>
     <p:bg>
@@ -5479,7 +5765,7 @@
 </p:sld>
 </file>
 
-<file path=ppt/slides/slide14.xml><?xml version="1.0" encoding="utf-8"?>
+<file path=ppt/slides/slide15.xml><?xml version="1.0" encoding="utf-8"?>
 <p:sld xmlns:a="http://schemas.openxmlformats.org/drawingml/2006/main" xmlns:p="http://schemas.openxmlformats.org/presentationml/2006/main" xmlns:r="http://schemas.openxmlformats.org/officeDocument/2006/relationships">
   <p:cSld>
     <p:bg>
@@ -5710,7 +5996,7 @@
 </p:sld>
 </file>
 
-<file path=ppt/slides/slide15.xml><?xml version="1.0" encoding="utf-8"?>
+<file path=ppt/slides/slide16.xml><?xml version="1.0" encoding="utf-8"?>
 <p:sld xmlns:a="http://schemas.openxmlformats.org/drawingml/2006/main" xmlns:p="http://schemas.openxmlformats.org/presentationml/2006/main" xmlns:r="http://schemas.openxmlformats.org/officeDocument/2006/relationships">
   <p:cSld>
     <p:bg>
@@ -7551,7 +7837,7 @@
               </a:defRPr>
             </a:pPr>
             <a:r>
-              <a:t>4.0 ĐÁNH GIÁ ĐƯỜNG CONG ROC &amp; AUC</a:t>
+              <a:t>4.0 TỐI ƯU HÓA SIÊU THAM SỐ (OPTUNA)</a:t>
             </a:r>
           </a:p>
           <a:p>
@@ -7564,7 +7850,7 @@
               </a:defRPr>
             </a:pPr>
             <a:r>
-              <a:t>Khả Năng Phân Tách Nhị Phân &amp; Ma Trận Nhầm Lẫn</a:t>
+              <a:t>Tối Ưu Siêu Tham Số Bayes Qua 12 Trials Với Optuna</a:t>
             </a:r>
           </a:p>
         </p:txBody>
@@ -7648,7 +7934,7 @@
               </a:defRPr>
             </a:pPr>
             <a:r>
-              <a:t>•  Đường cong ROC tiến sát góc trên bên trái, chứng minh độ nhạy cực cao.</a:t>
+              <a:t>•  Áp dụng Bayesian Optimization với TPE Sampler (Tree-structured Parzen Estimator).</a:t>
             </a:r>
           </a:p>
           <a:p>
@@ -7664,7 +7950,7 @@
               </a:defRPr>
             </a:pPr>
             <a:r>
-              <a:t>•  Test Accuracy đạt trên 99.8% cho các mô hình dạng cây, vượt trội so với Baseline (87.27%).</a:t>
+              <a:t>•  Champion XGBoost: Đạt ROC-AUC 0.9990 tại Trial #9 (n_estimators=140, max_depth=5, lr=0.0708).</a:t>
             </a:r>
           </a:p>
           <a:p>
@@ -7680,14 +7966,46 @@
               </a:defRPr>
             </a:pPr>
             <a:r>
-              <a:t>•  Tối thiểu hóa False Negatives (khách hàng rời bỏ nhưng đoán nhầm là ở lại), bảo toàn doanh thu doanh nghiệp.</a:t>
+              <a:t>•  Challenger Random Forest: Đạt ROC-AUC 0.9988 tại Trial #2 (n_estimators=60, max_depth=14).</a:t>
+            </a:r>
+          </a:p>
+          <a:p>
+            <a:pPr>
+              <a:spcAft>
+                <a:spcPts val="1000"/>
+              </a:spcAft>
+              <a:defRPr sz="1400">
+                <a:solidFill>
+                  <a:srgbClr val="F8FAFC"/>
+                </a:solidFill>
+                <a:latin typeface="Arial"/>
+              </a:defRPr>
+            </a:pPr>
+            <a:r>
+              <a:t>•  Phân tầng 3-Fold Stratified CV trên 25,000 mẫu đại diện, chống quá khớp (overfitting).</a:t>
+            </a:r>
+          </a:p>
+          <a:p>
+            <a:pPr>
+              <a:spcAft>
+                <a:spcPts val="1000"/>
+              </a:spcAft>
+              <a:defRPr sz="1400">
+                <a:solidFill>
+                  <a:srgbClr val="F8FAFC"/>
+                </a:solidFill>
+                <a:latin typeface="Arial"/>
+              </a:defRPr>
+            </a:pPr>
+            <a:r>
+              <a:t>•  Lưu vết toàn diện: Tự động ghi nhận trials vào tuning_history.json và sinh biểu đồ hội tụ.</a:t>
             </a:r>
           </a:p>
         </p:txBody>
       </p:sp>
       <p:pic>
         <p:nvPicPr>
-          <p:cNvPr id="5" name="Picture 4" descr="roc_curves.png"/>
+          <p:cNvPr id="5" name="Picture 4" descr="optuna_optimization.png"/>
           <p:cNvPicPr>
             <a:picLocks noChangeAspect="1"/>
           </p:cNvPicPr>
@@ -7702,7 +8020,7 @@
         <p:spPr>
           <a:xfrm>
             <a:off x="6492240" y="1554480"/>
-            <a:ext cx="4937760" cy="4232366"/>
+            <a:ext cx="4937760" cy="2468880"/>
           </a:xfrm>
           <a:prstGeom prst="rect">
             <a:avLst/>

</xml_diff>

<commit_message>
feat - release production ChurnGuard MLOps platform and technical documentation
</commit_message>
<xml_diff>
--- a/docs/Slide_Thuyet_Trinh_MLOps_Customer_Churn.pptx
+++ b/docs/Slide_Thuyet_Trinh_MLOps_Customer_Churn.pptx
@@ -1217,7 +1217,7 @@
           <a:lstStyle/>
           <a:p>
             <a:r>
-              <a:t>Thực nghiệm I/O đo đạc trực tiếp trên hệ thống cho thấy Parquet tiết kiệm 73% dung lượng lưu trữ và đọc nhanh hơn 14.4 lần so với CSV.</a:t>
+              <a:t>Nhóm triển khai Kiến trúc Nhị phân, vừa phục vụ bài toán Churn vừa đối chuẩn Big Data 5.28 GB qua DuckDB Out-of-Core với đỉnh RAM chỉ 85.1 MB.</a:t>
             </a:r>
           </a:p>
         </p:txBody>
@@ -1287,7 +1287,7 @@
           <a:lstStyle/>
           <a:p>
             <a:r>
-              <a:t>Kết quả đo đạc độ trễ mạng thực tế chứng minh Singapore là vị trí tối ưu nhất để đặt API gateway và container phục vụ người dùng Việt Nam.</a:t>
+              <a:t>Kết quả đo đạc độ trễ mạng thực tế chứng minh Singapore và Hong Kong là vị trí tối ưu nhất để đặt API gateway và container phục vụ người dùng Việt Nam.</a:t>
             </a:r>
           </a:p>
         </p:txBody>
@@ -4613,7 +4613,7 @@
               </a:defRPr>
             </a:pPr>
             <a:r>
-              <a:t>Giảng viên hướng dẫn: TS. Nguyễn Trọng Hải  |  Sinh viên thực hiện: Nguyễn Trọng Khởi (MSSV: 22520695)</a:t>
+              <a:t>Giảng viên hướng dẫn: ThS. Hà Lê Hoài Trung  |  Sinh viên thực hiện: Nguyễn Trọng Khởi (MSSV: 22520695)</a:t>
             </a:r>
           </a:p>
         </p:txBody>
@@ -7173,7 +7173,7 @@
               </a:defRPr>
             </a:pPr>
             <a:r>
-              <a:t>Thực Nghiệm Đo Kiểm Hiệu Năng Đọc Ghi Storage Thực Tế</a:t>
+              <a:t>Kiến Trúc Nhị Phân: Đo Kiểm I/O Storage &amp; Big Data (&gt;4GB)</a:t>
             </a:r>
           </a:p>
         </p:txBody>
@@ -7257,7 +7257,7 @@
               </a:defRPr>
             </a:pPr>
             <a:r>
-              <a:t>•  Đo đạc độc lập trên 100,000 bản ghi khách hàng (13 đặc trưng):</a:t>
+              <a:t>•  Track 1 (100k - 442k Churn): Parquet Snappy nén 3.7x, đọc 111.77 MB/s (nhanh hơn 14.4x so với CSV).</a:t>
             </a:r>
           </a:p>
           <a:p>
@@ -7273,7 +7273,7 @@
               </a:defRPr>
             </a:pPr>
             <a:r>
-              <a:t>•  CSV Plain Text: Dung lượng 8.94 MB | Ghi 16.78 MB/s | Đọc 28.68 MB/s.</a:t>
+              <a:t>•  Track 2 (Big Data &gt;4GB Scale Rubric 1.3): 42 triệu dòng (5.28 GB CSV -&gt; 1228.8 MB Parquet Snappy).</a:t>
             </a:r>
           </a:p>
           <a:p>
@@ -7289,7 +7289,7 @@
               </a:defRPr>
             </a:pPr>
             <a:r>
-              <a:t>•  Apache Parquet (Snappy): Dung lượng 2.42 MB (Nén 3.7x) | Tốc độ đọc 111.77 MB/s (Nhanh hơn 14.41x!).</a:t>
+              <a:t>•  Tỷ lệ nén dữ liệu lớn: 4.40x (Tiết kiệm 77.3% chi phí lưu trữ Azure Blob Storage).</a:t>
             </a:r>
           </a:p>
           <a:p>
@@ -7305,7 +7305,7 @@
               </a:defRPr>
             </a:pPr>
             <a:r>
-              <a:t>•  SQLite3 Relational DB: Dung lượng 5.58 MB | Ghi 22.59 MB/s | Đọc 15.37 MB/s.</a:t>
+              <a:t>•  Tốc độ đọc phân tích Out-of-Core: 6,144.0 MB/s (Nhanh gấp 16.84x so với quét tuần tự CSV).</a:t>
             </a:r>
           </a:p>
           <a:p>
@@ -7321,7 +7321,7 @@
               </a:defRPr>
             </a:pPr>
             <a:r>
-              <a:t>•  Kết luận: Parquet Snappy tối ưu vượt trội cho lưu trữ đám mây (S3/GCS/Blob) và Feast Offline Store.</a:t>
+              <a:t>•  Quản trị RAM psutil: Đỉnh RAM cố định 85.1 MB (O(1) Out-of-Core, an toàn dưới giới hạn 1,200 MB, No OOM).</a:t>
             </a:r>
           </a:p>
         </p:txBody>
@@ -7496,7 +7496,7 @@
               </a:defRPr>
             </a:pPr>
             <a:r>
-              <a:t>•  Đông Nam Á (Singapore / ap-southeast-1): 81.13 ms trung bình (Đạt chuẩn SLA tương tác &lt; 100ms).</a:t>
+              <a:t>•  Đông Nam Á (Singapore / Azure Southeast Asia): 49.17 ms trung bình (Đạt chuẩn SLA tương tác &lt; 50ms).</a:t>
             </a:r>
           </a:p>
           <a:p>
@@ -7512,7 +7512,7 @@
               </a:defRPr>
             </a:pPr>
             <a:r>
-              <a:t>•  Đông Á (Hong Kong / ap-east-1): 44.77 ms min, kết nối ổn định cho người dùng Châu Á.</a:t>
+              <a:t>•  Đông Á (Hong Kong / Azure East Asia): 38.34 ms min, 47.98 ms trung bình, kết nối ổn định cho Châu Á.</a:t>
             </a:r>
           </a:p>
           <a:p>
@@ -7528,7 +7528,7 @@
               </a:defRPr>
             </a:pPr>
             <a:r>
-              <a:t>•  Nhật Bản (Tokyo / ap-northeast-1): 168.28 ms | Frankfurt (eu-central-1): 262.10 ms.</a:t>
+              <a:t>•  Nhật Bản (Tokyo / Azure Japan East): 106.29 ms | Tây Âu (Netherlands / Azure West Europe): 216.59 ms.</a:t>
             </a:r>
           </a:p>
           <a:p>
@@ -7544,7 +7544,7 @@
               </a:defRPr>
             </a:pPr>
             <a:r>
-              <a:t>•  Bắc Mỹ (N. Virginia / us-east-1): 582.65 ms (Bắt buộc dùng CDN/Edge Proxy để tối ưu hóa trải nghiệm).</a:t>
+              <a:t>•  Bắc Mỹ (N. Virginia / Azure East US): 255.60 ms (Bắt buộc dùng CDN/Edge Proxy để tối ưu hóa trải nghiệm).</a:t>
             </a:r>
           </a:p>
         </p:txBody>

</xml_diff>